<commit_message>
Alle Logos und Favicons auf echtes Markenzeichen vereinheitlichen
Quelle: 07 Anhänge/WirkVektor Logo.svg (W + Teal-Pfeil). Bisherige
Platzhalter (favicon "WV"-Kachel, generischer logo-wv-Schriftzug) ersetzt.

- _build/sync_logos.py leitet aus dem Master eine transparente Variante
  und ein Favicon (Marke auf weißer, abgerundeter Kachel) ab und verteilt
  beide an Website (public + src/assets), Anhänge-Kopien und erzeugt ein
  PNG für die Office-Vorlagen
- Vorlagen: gezeichnetes "WV"-Quadrat durch echtes Logo ersetzt
  (docx-Briefkopf, pptx-Cover/Divider/Danke) und neu generiert
- DESIGN.md: Logo-Abschnitt ergänzt, Favicon-Beschreibung korrigiert
- Grafik-README + Projektnotiz aktualisiert

https://claude.ai/code/session_013egZ2k5Rzfr4iL9x1fQw48
</commit_message>
<xml_diff>
--- a/02 Projekte/Geschäftsausstattung und Vorlagen/Vorlagen/Präsentation/WirkVektor Master-Folien.pptx
+++ b/02 Projekte/Geschäftsausstattung und Vorlagen/Vorlagen/Präsentation/WirkVektor Master-Folien.pptx
@@ -3392,7 +3392,7 @@
         <p:spPr>
           <a:xfrm>
             <a:off x="841248" y="777240"/>
-            <a:ext cx="441655" cy="441655"/>
+            <a:ext cx="525780" cy="525780"/>
           </a:xfrm>
           <a:prstGeom prst="roundRect">
             <a:avLst>
@@ -3422,56 +3422,71 @@
           </a:fontRef>
         </p:style>
         <p:txBody>
-          <a:bodyPr rtlCol="0" anchor="ctr" wrap="none" lIns="0" rIns="0" tIns="0" bIns="0"/>
+          <a:bodyPr rtlCol="0" anchor="ctr"/>
           <a:lstStyle/>
           <a:p>
             <a:pPr algn="ctr"/>
-            <a:r>
-              <a:rPr sz="1725" b="1">
-                <a:solidFill>
-                  <a:srgbClr val="0F172A"/>
+          </a:p>
+        </p:txBody>
+      </p:sp>
+      <p:pic>
+        <p:nvPicPr>
+          <p:cNvPr id="3" name="Picture 2" descr="wv-logo.png"/>
+          <p:cNvPicPr>
+            <a:picLocks noChangeAspect="1"/>
+          </p:cNvPicPr>
+          <p:nvPr/>
+        </p:nvPicPr>
+        <p:blipFill>
+          <a:blip r:embed="rId2"/>
+          <a:stretch>
+            <a:fillRect/>
+          </a:stretch>
+        </p:blipFill>
+        <p:spPr>
+          <a:xfrm>
+            <a:off x="946404" y="882396"/>
+            <a:ext cx="315468" cy="315468"/>
+          </a:xfrm>
+          <a:prstGeom prst="rect">
+            <a:avLst/>
+          </a:prstGeom>
+        </p:spPr>
+      </p:pic>
+      <p:sp>
+        <p:nvSpPr>
+          <p:cNvPr id="4" name="TextBox 3"/>
+          <p:cNvSpPr txBox="1"/>
+          <p:nvPr/>
+        </p:nvSpPr>
+        <p:spPr>
+          <a:xfrm>
+            <a:off x="1531620" y="740664"/>
+            <a:ext cx="2926080" cy="617219"/>
+          </a:xfrm>
+          <a:prstGeom prst="rect">
+            <a:avLst/>
+          </a:prstGeom>
+          <a:noFill/>
+        </p:spPr>
+        <p:txBody>
+          <a:bodyPr wrap="square" anchor="ctr" lIns="0" rIns="0" tIns="0" bIns="0">
+            <a:spAutoFit/>
+          </a:bodyPr>
+          <a:lstStyle/>
+          <a:p>
+            <a:pPr algn="l">
+              <a:lnSpc>
+                <a:spcPct val="100000"/>
+              </a:lnSpc>
+            </a:pPr>
+            <a:r>
+              <a:rPr sz="1900" b="1">
+                <a:solidFill>
+                  <a:srgbClr val="FFFFFF"/>
                 </a:solidFill>
                 <a:latin typeface="Hanken Grotesk"/>
               </a:rPr>
-              <a:t>WV</a:t>
-            </a:r>
-          </a:p>
-        </p:txBody>
-      </p:sp>
-      <p:sp>
-        <p:nvSpPr>
-          <p:cNvPr id="3" name="TextBox 2"/>
-          <p:cNvSpPr txBox="1"/>
-          <p:nvPr/>
-        </p:nvSpPr>
-        <p:spPr>
-          <a:xfrm>
-            <a:off x="1429207" y="740664"/>
-            <a:ext cx="2743200" cy="533095"/>
-          </a:xfrm>
-          <a:prstGeom prst="rect">
-            <a:avLst/>
-          </a:prstGeom>
-          <a:noFill/>
-        </p:spPr>
-        <p:txBody>
-          <a:bodyPr wrap="square" anchor="ctr" lIns="0" rIns="0" tIns="0" bIns="0">
-            <a:spAutoFit/>
-          </a:bodyPr>
-          <a:lstStyle/>
-          <a:p>
-            <a:pPr algn="l">
-              <a:lnSpc>
-                <a:spcPct val="100000"/>
-              </a:lnSpc>
-            </a:pPr>
-            <a:r>
-              <a:rPr sz="1900" b="1">
-                <a:solidFill>
-                  <a:srgbClr val="FFFFFF"/>
-                </a:solidFill>
-                <a:latin typeface="Hanken Grotesk"/>
-              </a:rPr>
               <a:t>WirkVektor</a:t>
             </a:r>
           </a:p>
@@ -3479,7 +3494,7 @@
       </p:sp>
       <p:sp>
         <p:nvSpPr>
-          <p:cNvPr id="4" name="Rectangle 3"/>
+          <p:cNvPr id="5" name="Rectangle 4"/>
           <p:cNvSpPr/>
           <p:nvPr/>
         </p:nvSpPr>
@@ -3523,7 +3538,7 @@
       </p:sp>
       <p:sp>
         <p:nvSpPr>
-          <p:cNvPr id="5" name="TextBox 4"/>
+          <p:cNvPr id="6" name="TextBox 5"/>
           <p:cNvSpPr txBox="1"/>
           <p:nvPr/>
         </p:nvSpPr>
@@ -3562,7 +3577,7 @@
       </p:sp>
       <p:sp>
         <p:nvSpPr>
-          <p:cNvPr id="6" name="TextBox 5"/>
+          <p:cNvPr id="7" name="TextBox 6"/>
           <p:cNvSpPr txBox="1"/>
           <p:nvPr/>
         </p:nvSpPr>
@@ -3617,7 +3632,7 @@
       </p:sp>
       <p:sp>
         <p:nvSpPr>
-          <p:cNvPr id="7" name="Rectangle 6"/>
+          <p:cNvPr id="8" name="Rectangle 7"/>
           <p:cNvSpPr/>
           <p:nvPr/>
         </p:nvSpPr>
@@ -3661,7 +3676,7 @@
       </p:sp>
       <p:sp>
         <p:nvSpPr>
-          <p:cNvPr id="8" name="TextBox 7"/>
+          <p:cNvPr id="9" name="TextBox 8"/>
           <p:cNvSpPr txBox="1"/>
           <p:nvPr/>
         </p:nvSpPr>
@@ -3700,7 +3715,7 @@
       </p:sp>
       <p:sp>
         <p:nvSpPr>
-          <p:cNvPr id="9" name="Chevron 8"/>
+          <p:cNvPr id="10" name="Chevron 9"/>
           <p:cNvSpPr/>
           <p:nvPr/>
         </p:nvSpPr>
@@ -11829,61 +11844,30 @@
         <p:nvPr/>
       </p:nvGrpSpPr>
       <p:grpSpPr/>
-      <p:sp>
-        <p:nvSpPr>
-          <p:cNvPr id="2" name="Rounded Rectangle 1"/>
-          <p:cNvSpPr/>
-          <p:nvPr/>
-        </p:nvSpPr>
+      <p:pic>
+        <p:nvPicPr>
+          <p:cNvPr id="2" name="Picture 1" descr="wv-logo.png"/>
+          <p:cNvPicPr>
+            <a:picLocks noChangeAspect="1"/>
+          </p:cNvPicPr>
+          <p:nvPr/>
+        </p:nvPicPr>
+        <p:blipFill>
+          <a:blip r:embed="rId2"/>
+          <a:stretch>
+            <a:fillRect/>
+          </a:stretch>
+        </p:blipFill>
         <p:spPr>
           <a:xfrm>
             <a:off x="841248" y="777240"/>
-            <a:ext cx="422452" cy="422452"/>
-          </a:xfrm>
-          <a:prstGeom prst="roundRect">
-            <a:avLst>
-              <a:gd name="adj" fmla="val 16000"/>
-            </a:avLst>
-          </a:prstGeom>
-          <a:solidFill>
-            <a:srgbClr val="0F172A"/>
-          </a:solidFill>
-          <a:ln>
-            <a:noFill/>
-          </a:ln>
-          <a:effectLst/>
-        </p:spPr>
-        <p:style>
-          <a:lnRef idx="1">
-            <a:schemeClr val="accent1"/>
-          </a:lnRef>
-          <a:fillRef idx="3">
-            <a:schemeClr val="accent1"/>
-          </a:fillRef>
-          <a:effectRef idx="2">
-            <a:schemeClr val="accent1"/>
-          </a:effectRef>
-          <a:fontRef idx="minor">
-            <a:schemeClr val="lt1"/>
-          </a:fontRef>
-        </p:style>
-        <p:txBody>
-          <a:bodyPr rtlCol="0" anchor="ctr" wrap="none" lIns="0" rIns="0" tIns="0" bIns="0"/>
-          <a:lstStyle/>
-          <a:p>
-            <a:pPr algn="ctr"/>
-            <a:r>
-              <a:rPr sz="1650" b="1">
-                <a:solidFill>
-                  <a:srgbClr val="FFFFFF"/>
-                </a:solidFill>
-                <a:latin typeface="Hanken Grotesk"/>
-              </a:rPr>
-              <a:t>WV</a:t>
-            </a:r>
-          </a:p>
-        </p:txBody>
-      </p:sp>
+            <a:ext cx="502920" cy="502920"/>
+          </a:xfrm>
+          <a:prstGeom prst="rect">
+            <a:avLst/>
+          </a:prstGeom>
+        </p:spPr>
+      </p:pic>
       <p:sp>
         <p:nvSpPr>
           <p:cNvPr id="3" name="TextBox 2"/>
@@ -11892,8 +11876,8 @@
         </p:nvSpPr>
         <p:spPr>
           <a:xfrm>
-            <a:off x="1410004" y="740664"/>
-            <a:ext cx="2743200" cy="513892"/>
+            <a:off x="1508760" y="740664"/>
+            <a:ext cx="2926080" cy="594360"/>
           </a:xfrm>
           <a:prstGeom prst="rect">
             <a:avLst/>
@@ -16833,7 +16817,7 @@
         <p:spPr>
           <a:xfrm>
             <a:off x="841248" y="822960"/>
-            <a:ext cx="384048" cy="384048"/>
+            <a:ext cx="457200" cy="457200"/>
           </a:xfrm>
           <a:prstGeom prst="roundRect">
             <a:avLst>
@@ -16863,56 +16847,71 @@
           </a:fontRef>
         </p:style>
         <p:txBody>
-          <a:bodyPr rtlCol="0" anchor="ctr" wrap="none" lIns="0" rIns="0" tIns="0" bIns="0"/>
+          <a:bodyPr rtlCol="0" anchor="ctr"/>
           <a:lstStyle/>
           <a:p>
             <a:pPr algn="ctr"/>
-            <a:r>
-              <a:rPr sz="1500" b="1">
-                <a:solidFill>
-                  <a:srgbClr val="0F172A"/>
+          </a:p>
+        </p:txBody>
+      </p:sp>
+      <p:pic>
+        <p:nvPicPr>
+          <p:cNvPr id="3" name="Picture 2" descr="wv-logo.png"/>
+          <p:cNvPicPr>
+            <a:picLocks noChangeAspect="1"/>
+          </p:cNvPicPr>
+          <p:nvPr/>
+        </p:nvPicPr>
+        <p:blipFill>
+          <a:blip r:embed="rId2"/>
+          <a:stretch>
+            <a:fillRect/>
+          </a:stretch>
+        </p:blipFill>
+        <p:spPr>
+          <a:xfrm>
+            <a:off x="932688" y="914400"/>
+            <a:ext cx="274320" cy="274320"/>
+          </a:xfrm>
+          <a:prstGeom prst="rect">
+            <a:avLst/>
+          </a:prstGeom>
+        </p:spPr>
+      </p:pic>
+      <p:sp>
+        <p:nvSpPr>
+          <p:cNvPr id="4" name="TextBox 3"/>
+          <p:cNvSpPr txBox="1"/>
+          <p:nvPr/>
+        </p:nvSpPr>
+        <p:spPr>
+          <a:xfrm>
+            <a:off x="1463039" y="786384"/>
+            <a:ext cx="2926080" cy="548640"/>
+          </a:xfrm>
+          <a:prstGeom prst="rect">
+            <a:avLst/>
+          </a:prstGeom>
+          <a:noFill/>
+        </p:spPr>
+        <p:txBody>
+          <a:bodyPr wrap="square" anchor="ctr" lIns="0" rIns="0" tIns="0" bIns="0">
+            <a:spAutoFit/>
+          </a:bodyPr>
+          <a:lstStyle/>
+          <a:p>
+            <a:pPr algn="l">
+              <a:lnSpc>
+                <a:spcPct val="100000"/>
+              </a:lnSpc>
+            </a:pPr>
+            <a:r>
+              <a:rPr sz="1700" b="1">
+                <a:solidFill>
+                  <a:srgbClr val="FFFFFF"/>
                 </a:solidFill>
                 <a:latin typeface="Hanken Grotesk"/>
               </a:rPr>
-              <a:t>WV</a:t>
-            </a:r>
-          </a:p>
-        </p:txBody>
-      </p:sp>
-      <p:sp>
-        <p:nvSpPr>
-          <p:cNvPr id="3" name="TextBox 2"/>
-          <p:cNvSpPr txBox="1"/>
-          <p:nvPr/>
-        </p:nvSpPr>
-        <p:spPr>
-          <a:xfrm>
-            <a:off x="1371600" y="786384"/>
-            <a:ext cx="2743200" cy="475488"/>
-          </a:xfrm>
-          <a:prstGeom prst="rect">
-            <a:avLst/>
-          </a:prstGeom>
-          <a:noFill/>
-        </p:spPr>
-        <p:txBody>
-          <a:bodyPr wrap="square" anchor="ctr" lIns="0" rIns="0" tIns="0" bIns="0">
-            <a:spAutoFit/>
-          </a:bodyPr>
-          <a:lstStyle/>
-          <a:p>
-            <a:pPr algn="l">
-              <a:lnSpc>
-                <a:spcPct val="100000"/>
-              </a:lnSpc>
-            </a:pPr>
-            <a:r>
-              <a:rPr sz="1700" b="1">
-                <a:solidFill>
-                  <a:srgbClr val="FFFFFF"/>
-                </a:solidFill>
-                <a:latin typeface="Hanken Grotesk"/>
-              </a:rPr>
               <a:t>WirkVektor</a:t>
             </a:r>
           </a:p>
@@ -16920,7 +16919,7 @@
       </p:sp>
       <p:sp>
         <p:nvSpPr>
-          <p:cNvPr id="4" name="TextBox 3"/>
+          <p:cNvPr id="5" name="TextBox 4"/>
           <p:cNvSpPr txBox="1"/>
           <p:nvPr/>
         </p:nvSpPr>
@@ -16959,7 +16958,7 @@
       </p:sp>
       <p:sp>
         <p:nvSpPr>
-          <p:cNvPr id="5" name="Rectangle 4"/>
+          <p:cNvPr id="6" name="Rectangle 5"/>
           <p:cNvSpPr/>
           <p:nvPr/>
         </p:nvSpPr>
@@ -17003,7 +17002,7 @@
       </p:sp>
       <p:sp>
         <p:nvSpPr>
-          <p:cNvPr id="6" name="TextBox 5"/>
+          <p:cNvPr id="7" name="TextBox 6"/>
           <p:cNvSpPr txBox="1"/>
           <p:nvPr/>
         </p:nvSpPr>
@@ -18963,7 +18962,7 @@
         <p:spPr>
           <a:xfrm>
             <a:off x="841248" y="5852160"/>
-            <a:ext cx="345643" cy="345643"/>
+            <a:ext cx="411480" cy="411480"/>
           </a:xfrm>
           <a:prstGeom prst="roundRect">
             <a:avLst>
@@ -18993,32 +18992,47 @@
           </a:fontRef>
         </p:style>
         <p:txBody>
-          <a:bodyPr rtlCol="0" anchor="ctr" wrap="none" lIns="0" rIns="0" tIns="0" bIns="0"/>
+          <a:bodyPr rtlCol="0" anchor="ctr"/>
           <a:lstStyle/>
           <a:p>
             <a:pPr algn="ctr"/>
-            <a:r>
-              <a:rPr sz="1350" b="1">
-                <a:solidFill>
-                  <a:srgbClr val="0F172A"/>
-                </a:solidFill>
-                <a:latin typeface="Hanken Grotesk"/>
-              </a:rPr>
-              <a:t>WV</a:t>
-            </a:r>
-          </a:p>
-        </p:txBody>
-      </p:sp>
-      <p:sp>
-        <p:nvSpPr>
-          <p:cNvPr id="6" name="TextBox 5"/>
-          <p:cNvSpPr txBox="1"/>
-          <p:nvPr/>
-        </p:nvSpPr>
-        <p:spPr>
-          <a:xfrm>
-            <a:off x="1333195" y="5815584"/>
-            <a:ext cx="2743200" cy="437083"/>
+          </a:p>
+        </p:txBody>
+      </p:sp>
+      <p:pic>
+        <p:nvPicPr>
+          <p:cNvPr id="6" name="Picture 5" descr="wv-logo.png"/>
+          <p:cNvPicPr>
+            <a:picLocks noChangeAspect="1"/>
+          </p:cNvPicPr>
+          <p:nvPr/>
+        </p:nvPicPr>
+        <p:blipFill>
+          <a:blip r:embed="rId2"/>
+          <a:stretch>
+            <a:fillRect/>
+          </a:stretch>
+        </p:blipFill>
+        <p:spPr>
+          <a:xfrm>
+            <a:off x="923544" y="5934456"/>
+            <a:ext cx="246888" cy="246888"/>
+          </a:xfrm>
+          <a:prstGeom prst="rect">
+            <a:avLst/>
+          </a:prstGeom>
+        </p:spPr>
+      </p:pic>
+      <p:sp>
+        <p:nvSpPr>
+          <p:cNvPr id="7" name="TextBox 6"/>
+          <p:cNvSpPr txBox="1"/>
+          <p:nvPr/>
+        </p:nvSpPr>
+        <p:spPr>
+          <a:xfrm>
+            <a:off x="1417320" y="5815584"/>
+            <a:ext cx="2926080" cy="502920"/>
           </a:xfrm>
           <a:prstGeom prst="rect">
             <a:avLst/>

</xml_diff>

<commit_message>
Logo: Root-Datei wortgetreu verwenden (statt abgeleiteter Variante)
Auf Wunsch wird 07 Anhänge/WirkVektor Logo.svg unverändert (inkl. weißem
Hintergrund) an allen Stellen eingesetzt:

- sync_logos.py kopiert die Root-Datei 1:1 an Website, Favicon und
  Anhänge-Kopien und rendert das Vorlagen-PNG direkt daraus
- pptx-logo() vereinfacht (keine separate weiße Kachel mehr nötig)
- Vorlagen neu generiert; DESIGN.md + README-Beschreibungen angepasst

https://claude.ai/code/session_013egZ2k5Rzfr4iL9x1fQw48
</commit_message>
<xml_diff>
--- a/02 Projekte/Geschäftsausstattung und Vorlagen/Vorlagen/Präsentation/WirkVektor Master-Folien.pptx
+++ b/02 Projekte/Geschäftsausstattung und Vorlagen/Vorlagen/Präsentation/WirkVektor Master-Folien.pptx
@@ -3383,55 +3383,9 @@
         <p:nvPr/>
       </p:nvGrpSpPr>
       <p:grpSpPr/>
-      <p:sp>
-        <p:nvSpPr>
-          <p:cNvPr id="2" name="Rounded Rectangle 1"/>
-          <p:cNvSpPr/>
-          <p:nvPr/>
-        </p:nvSpPr>
-        <p:spPr>
-          <a:xfrm>
-            <a:off x="841248" y="777240"/>
-            <a:ext cx="525780" cy="525780"/>
-          </a:xfrm>
-          <a:prstGeom prst="roundRect">
-            <a:avLst>
-              <a:gd name="adj" fmla="val 16000"/>
-            </a:avLst>
-          </a:prstGeom>
-          <a:solidFill>
-            <a:srgbClr val="FFFFFF"/>
-          </a:solidFill>
-          <a:ln>
-            <a:noFill/>
-          </a:ln>
-          <a:effectLst/>
-        </p:spPr>
-        <p:style>
-          <a:lnRef idx="1">
-            <a:schemeClr val="accent1"/>
-          </a:lnRef>
-          <a:fillRef idx="3">
-            <a:schemeClr val="accent1"/>
-          </a:fillRef>
-          <a:effectRef idx="2">
-            <a:schemeClr val="accent1"/>
-          </a:effectRef>
-          <a:fontRef idx="minor">
-            <a:schemeClr val="lt1"/>
-          </a:fontRef>
-        </p:style>
-        <p:txBody>
-          <a:bodyPr rtlCol="0" anchor="ctr"/>
-          <a:lstStyle/>
-          <a:p>
-            <a:pPr algn="ctr"/>
-          </a:p>
-        </p:txBody>
-      </p:sp>
       <p:pic>
         <p:nvPicPr>
-          <p:cNvPr id="3" name="Picture 2" descr="wv-logo.png"/>
+          <p:cNvPr id="2" name="Picture 1" descr="wv-logo.png"/>
           <p:cNvPicPr>
             <a:picLocks noChangeAspect="1"/>
           </p:cNvPicPr>
@@ -3445,8 +3399,8 @@
         </p:blipFill>
         <p:spPr>
           <a:xfrm>
-            <a:off x="946404" y="882396"/>
-            <a:ext cx="315468" cy="315468"/>
+            <a:off x="841248" y="777240"/>
+            <a:ext cx="651967" cy="651967"/>
           </a:xfrm>
           <a:prstGeom prst="rect">
             <a:avLst/>
@@ -3455,14 +3409,14 @@
       </p:pic>
       <p:sp>
         <p:nvSpPr>
-          <p:cNvPr id="4" name="TextBox 3"/>
-          <p:cNvSpPr txBox="1"/>
-          <p:nvPr/>
-        </p:nvSpPr>
-        <p:spPr>
-          <a:xfrm>
-            <a:off x="1531620" y="740664"/>
-            <a:ext cx="2926080" cy="617219"/>
+          <p:cNvPr id="3" name="TextBox 2"/>
+          <p:cNvSpPr txBox="1"/>
+          <p:nvPr/>
+        </p:nvSpPr>
+        <p:spPr>
+          <a:xfrm>
+            <a:off x="1657807" y="740664"/>
+            <a:ext cx="2926080" cy="743407"/>
           </a:xfrm>
           <a:prstGeom prst="rect">
             <a:avLst/>
@@ -3494,7 +3448,7 @@
       </p:sp>
       <p:sp>
         <p:nvSpPr>
-          <p:cNvPr id="5" name="Rectangle 4"/>
+          <p:cNvPr id="4" name="Rectangle 3"/>
           <p:cNvSpPr/>
           <p:nvPr/>
         </p:nvSpPr>
@@ -3538,7 +3492,7 @@
       </p:sp>
       <p:sp>
         <p:nvSpPr>
-          <p:cNvPr id="6" name="TextBox 5"/>
+          <p:cNvPr id="5" name="TextBox 4"/>
           <p:cNvSpPr txBox="1"/>
           <p:nvPr/>
         </p:nvSpPr>
@@ -3577,7 +3531,7 @@
       </p:sp>
       <p:sp>
         <p:nvSpPr>
-          <p:cNvPr id="7" name="TextBox 6"/>
+          <p:cNvPr id="6" name="TextBox 5"/>
           <p:cNvSpPr txBox="1"/>
           <p:nvPr/>
         </p:nvSpPr>
@@ -3632,7 +3586,7 @@
       </p:sp>
       <p:sp>
         <p:nvSpPr>
-          <p:cNvPr id="8" name="Rectangle 7"/>
+          <p:cNvPr id="7" name="Rectangle 6"/>
           <p:cNvSpPr/>
           <p:nvPr/>
         </p:nvSpPr>
@@ -3676,7 +3630,7 @@
       </p:sp>
       <p:sp>
         <p:nvSpPr>
-          <p:cNvPr id="9" name="TextBox 8"/>
+          <p:cNvPr id="8" name="TextBox 7"/>
           <p:cNvSpPr txBox="1"/>
           <p:nvPr/>
         </p:nvSpPr>
@@ -3715,7 +3669,7 @@
       </p:sp>
       <p:sp>
         <p:nvSpPr>
-          <p:cNvPr id="10" name="Chevron 9"/>
+          <p:cNvPr id="9" name="Chevron 8"/>
           <p:cNvSpPr/>
           <p:nvPr/>
         </p:nvSpPr>
@@ -11861,7 +11815,7 @@
         <p:spPr>
           <a:xfrm>
             <a:off x="841248" y="777240"/>
-            <a:ext cx="502920" cy="502920"/>
+            <a:ext cx="623620" cy="623620"/>
           </a:xfrm>
           <a:prstGeom prst="rect">
             <a:avLst/>
@@ -11876,8 +11830,8 @@
         </p:nvSpPr>
         <p:spPr>
           <a:xfrm>
-            <a:off x="1508760" y="740664"/>
-            <a:ext cx="2926080" cy="594360"/>
+            <a:off x="1629460" y="740664"/>
+            <a:ext cx="2926080" cy="715060"/>
           </a:xfrm>
           <a:prstGeom prst="rect">
             <a:avLst/>
@@ -16808,55 +16762,9 @@
         <p:nvPr/>
       </p:nvGrpSpPr>
       <p:grpSpPr/>
-      <p:sp>
-        <p:nvSpPr>
-          <p:cNvPr id="2" name="Rounded Rectangle 1"/>
-          <p:cNvSpPr/>
-          <p:nvPr/>
-        </p:nvSpPr>
-        <p:spPr>
-          <a:xfrm>
-            <a:off x="841248" y="822960"/>
-            <a:ext cx="457200" cy="457200"/>
-          </a:xfrm>
-          <a:prstGeom prst="roundRect">
-            <a:avLst>
-              <a:gd name="adj" fmla="val 16000"/>
-            </a:avLst>
-          </a:prstGeom>
-          <a:solidFill>
-            <a:srgbClr val="FFFFFF"/>
-          </a:solidFill>
-          <a:ln>
-            <a:noFill/>
-          </a:ln>
-          <a:effectLst/>
-        </p:spPr>
-        <p:style>
-          <a:lnRef idx="1">
-            <a:schemeClr val="accent1"/>
-          </a:lnRef>
-          <a:fillRef idx="3">
-            <a:schemeClr val="accent1"/>
-          </a:fillRef>
-          <a:effectRef idx="2">
-            <a:schemeClr val="accent1"/>
-          </a:effectRef>
-          <a:fontRef idx="minor">
-            <a:schemeClr val="lt1"/>
-          </a:fontRef>
-        </p:style>
-        <p:txBody>
-          <a:bodyPr rtlCol="0" anchor="ctr"/>
-          <a:lstStyle/>
-          <a:p>
-            <a:pPr algn="ctr"/>
-          </a:p>
-        </p:txBody>
-      </p:sp>
       <p:pic>
         <p:nvPicPr>
-          <p:cNvPr id="3" name="Picture 2" descr="wv-logo.png"/>
+          <p:cNvPr id="2" name="Picture 1" descr="wv-logo.png"/>
           <p:cNvPicPr>
             <a:picLocks noChangeAspect="1"/>
           </p:cNvPicPr>
@@ -16870,8 +16778,8 @@
         </p:blipFill>
         <p:spPr>
           <a:xfrm>
-            <a:off x="932688" y="914400"/>
-            <a:ext cx="274320" cy="274320"/>
+            <a:off x="841248" y="822960"/>
+            <a:ext cx="566928" cy="566928"/>
           </a:xfrm>
           <a:prstGeom prst="rect">
             <a:avLst/>
@@ -16880,46 +16788,46 @@
       </p:pic>
       <p:sp>
         <p:nvSpPr>
+          <p:cNvPr id="3" name="TextBox 2"/>
+          <p:cNvSpPr txBox="1"/>
+          <p:nvPr/>
+        </p:nvSpPr>
+        <p:spPr>
+          <a:xfrm>
+            <a:off x="1572768" y="786384"/>
+            <a:ext cx="2926080" cy="658368"/>
+          </a:xfrm>
+          <a:prstGeom prst="rect">
+            <a:avLst/>
+          </a:prstGeom>
+          <a:noFill/>
+        </p:spPr>
+        <p:txBody>
+          <a:bodyPr wrap="square" anchor="ctr" lIns="0" rIns="0" tIns="0" bIns="0">
+            <a:spAutoFit/>
+          </a:bodyPr>
+          <a:lstStyle/>
+          <a:p>
+            <a:pPr algn="l">
+              <a:lnSpc>
+                <a:spcPct val="100000"/>
+              </a:lnSpc>
+            </a:pPr>
+            <a:r>
+              <a:rPr sz="1700" b="1">
+                <a:solidFill>
+                  <a:srgbClr val="FFFFFF"/>
+                </a:solidFill>
+                <a:latin typeface="Hanken Grotesk"/>
+              </a:rPr>
+              <a:t>WirkVektor</a:t>
+            </a:r>
+          </a:p>
+        </p:txBody>
+      </p:sp>
+      <p:sp>
+        <p:nvSpPr>
           <p:cNvPr id="4" name="TextBox 3"/>
-          <p:cNvSpPr txBox="1"/>
-          <p:nvPr/>
-        </p:nvSpPr>
-        <p:spPr>
-          <a:xfrm>
-            <a:off x="1463039" y="786384"/>
-            <a:ext cx="2926080" cy="548640"/>
-          </a:xfrm>
-          <a:prstGeom prst="rect">
-            <a:avLst/>
-          </a:prstGeom>
-          <a:noFill/>
-        </p:spPr>
-        <p:txBody>
-          <a:bodyPr wrap="square" anchor="ctr" lIns="0" rIns="0" tIns="0" bIns="0">
-            <a:spAutoFit/>
-          </a:bodyPr>
-          <a:lstStyle/>
-          <a:p>
-            <a:pPr algn="l">
-              <a:lnSpc>
-                <a:spcPct val="100000"/>
-              </a:lnSpc>
-            </a:pPr>
-            <a:r>
-              <a:rPr sz="1700" b="1">
-                <a:solidFill>
-                  <a:srgbClr val="FFFFFF"/>
-                </a:solidFill>
-                <a:latin typeface="Hanken Grotesk"/>
-              </a:rPr>
-              <a:t>WirkVektor</a:t>
-            </a:r>
-          </a:p>
-        </p:txBody>
-      </p:sp>
-      <p:sp>
-        <p:nvSpPr>
-          <p:cNvPr id="5" name="TextBox 4"/>
           <p:cNvSpPr txBox="1"/>
           <p:nvPr/>
         </p:nvSpPr>
@@ -16958,7 +16866,7 @@
       </p:sp>
       <p:sp>
         <p:nvSpPr>
-          <p:cNvPr id="6" name="Rectangle 5"/>
+          <p:cNvPr id="5" name="Rectangle 4"/>
           <p:cNvSpPr/>
           <p:nvPr/>
         </p:nvSpPr>
@@ -17002,7 +16910,7 @@
       </p:sp>
       <p:sp>
         <p:nvSpPr>
-          <p:cNvPr id="7" name="TextBox 6"/>
+          <p:cNvPr id="6" name="TextBox 5"/>
           <p:cNvSpPr txBox="1"/>
           <p:nvPr/>
         </p:nvSpPr>
@@ -18953,55 +18861,9 @@
           </a:p>
         </p:txBody>
       </p:sp>
-      <p:sp>
-        <p:nvSpPr>
-          <p:cNvPr id="5" name="Rounded Rectangle 4"/>
-          <p:cNvSpPr/>
-          <p:nvPr/>
-        </p:nvSpPr>
-        <p:spPr>
-          <a:xfrm>
-            <a:off x="841248" y="5852160"/>
-            <a:ext cx="411480" cy="411480"/>
-          </a:xfrm>
-          <a:prstGeom prst="roundRect">
-            <a:avLst>
-              <a:gd name="adj" fmla="val 16000"/>
-            </a:avLst>
-          </a:prstGeom>
-          <a:solidFill>
-            <a:srgbClr val="FFFFFF"/>
-          </a:solidFill>
-          <a:ln>
-            <a:noFill/>
-          </a:ln>
-          <a:effectLst/>
-        </p:spPr>
-        <p:style>
-          <a:lnRef idx="1">
-            <a:schemeClr val="accent1"/>
-          </a:lnRef>
-          <a:fillRef idx="3">
-            <a:schemeClr val="accent1"/>
-          </a:fillRef>
-          <a:effectRef idx="2">
-            <a:schemeClr val="accent1"/>
-          </a:effectRef>
-          <a:fontRef idx="minor">
-            <a:schemeClr val="lt1"/>
-          </a:fontRef>
-        </p:style>
-        <p:txBody>
-          <a:bodyPr rtlCol="0" anchor="ctr"/>
-          <a:lstStyle/>
-          <a:p>
-            <a:pPr algn="ctr"/>
-          </a:p>
-        </p:txBody>
-      </p:sp>
       <p:pic>
         <p:nvPicPr>
-          <p:cNvPr id="6" name="Picture 5" descr="wv-logo.png"/>
+          <p:cNvPr id="5" name="Picture 4" descr="wv-logo.png"/>
           <p:cNvPicPr>
             <a:picLocks noChangeAspect="1"/>
           </p:cNvPicPr>
@@ -19015,8 +18877,8 @@
         </p:blipFill>
         <p:spPr>
           <a:xfrm>
-            <a:off x="923544" y="5934456"/>
-            <a:ext cx="246888" cy="246888"/>
+            <a:off x="841248" y="5852160"/>
+            <a:ext cx="510235" cy="510235"/>
           </a:xfrm>
           <a:prstGeom prst="rect">
             <a:avLst/>
@@ -19025,14 +18887,14 @@
       </p:pic>
       <p:sp>
         <p:nvSpPr>
-          <p:cNvPr id="7" name="TextBox 6"/>
-          <p:cNvSpPr txBox="1"/>
-          <p:nvPr/>
-        </p:nvSpPr>
-        <p:spPr>
-          <a:xfrm>
-            <a:off x="1417320" y="5815584"/>
-            <a:ext cx="2926080" cy="502920"/>
+          <p:cNvPr id="6" name="TextBox 5"/>
+          <p:cNvSpPr txBox="1"/>
+          <p:nvPr/>
+        </p:nvSpPr>
+        <p:spPr>
+          <a:xfrm>
+            <a:off x="1516075" y="5815584"/>
+            <a:ext cx="2926080" cy="601675"/>
           </a:xfrm>
           <a:prstGeom prst="rect">
             <a:avLst/>

</xml_diff>